<commit_message>
docs: update five-member team assignments
</commit_message>
<xml_diff>
--- a/学林街之狼项目立项答辩PPT.pptx
+++ b/学林街之狼项目立项答辩PPT.pptx
@@ -2319,7 +2319,7 @@
                 <a:ea typeface="Microsoft YaHei" pitchFamily="34" charset="-122"/>
                 <a:cs typeface="Microsoft YaHei" pitchFamily="34" charset="-120"/>
               </a:rPr>
-              <a:t>四人协作开发 | 前端原型项目</a:t>
+              <a:t>五人协作开发 | 前端原型项目</a:t>
             </a:r>
             <a:endParaRPr lang="en-US" sz="1200" dirty="0"/>
           </a:p>
@@ -8360,12 +8360,12 @@
         </p:nvSpPr>
         <p:spPr>
           <a:xfrm>
-            <a:off x="640080" y="1874520"/>
-            <a:ext cx="5056632" cy="1298448"/>
+            <a:off x="640080" y="1828800"/>
+            <a:ext cx="3429000" cy="1188720"/>
           </a:xfrm>
           <a:prstGeom prst="roundRect">
             <a:avLst>
-              <a:gd name="adj" fmla="val 3521"/>
+              <a:gd name="adj" fmla="val 3846"/>
             </a:avLst>
           </a:prstGeom>
           <a:solidFill>
@@ -8387,7 +8387,7 @@
         </p:nvSpPr>
         <p:spPr>
           <a:xfrm>
-            <a:off x="896112" y="2212848"/>
+            <a:off x="896112" y="2167128"/>
             <a:ext cx="621792" cy="621792"/>
           </a:xfrm>
           <a:prstGeom prst="ellipse">
@@ -8412,7 +8412,7 @@
         </p:nvSpPr>
         <p:spPr>
           <a:xfrm>
-            <a:off x="896112" y="2404872"/>
+            <a:off x="896112" y="2359152"/>
             <a:ext cx="621792" cy="164592"/>
           </a:xfrm>
           <a:prstGeom prst="rect">
@@ -8439,7 +8439,7 @@
                 <a:ea typeface="Microsoft YaHei" pitchFamily="34" charset="-122"/>
                 <a:cs typeface="Microsoft YaHei" pitchFamily="34" charset="-120"/>
               </a:rPr>
-              <a:t>A</a:t>
+              <a:t>1</a:t>
             </a:r>
             <a:endParaRPr lang="en-US" sz="1100" dirty="0"/>
           </a:p>
@@ -8453,8 +8453,8 @@
         </p:nvSpPr>
         <p:spPr>
           <a:xfrm>
-            <a:off x="1719072" y="2112264"/>
-            <a:ext cx="914400" cy="228600"/>
+            <a:off x="1719072" y="2011680"/>
+            <a:ext cx="2057400" cy="219456"/>
           </a:xfrm>
           <a:prstGeom prst="rect">
             <a:avLst/>
@@ -8472,7 +8472,7 @@
               <a:buNone/>
             </a:pPr>
             <a:r>
-              <a:rPr lang="en-US" sz="1300" b="1" dirty="0">
+              <a:rPr lang="en-US" sz="1200" b="1" dirty="0">
                 <a:solidFill>
                   <a:srgbClr val="19241F"/>
                 </a:solidFill>
@@ -8480,9 +8480,9 @@
                 <a:ea typeface="Microsoft YaHei" pitchFamily="34" charset="-122"/>
                 <a:cs typeface="Microsoft YaHei" pitchFamily="34" charset="-120"/>
               </a:rPr>
-              <a:t>成员 A</a:t>
-            </a:r>
-            <a:endParaRPr lang="en-US" sz="1300" dirty="0"/>
+              <a:t>钟森翔</a:t>
+            </a:r>
+            <a:endParaRPr lang="en-US" sz="1200" dirty="0"/>
           </a:p>
         </p:txBody>
       </p:sp>
@@ -8494,8 +8494,8 @@
         </p:nvSpPr>
         <p:spPr>
           <a:xfrm>
-            <a:off x="2633472" y="2112264"/>
-            <a:ext cx="2606040" cy="228600"/>
+            <a:off x="1719072" y="2295144"/>
+            <a:ext cx="2057400" cy="219456"/>
           </a:xfrm>
           <a:prstGeom prst="rect">
             <a:avLst/>
@@ -8513,9 +8513,9 @@
               <a:buNone/>
             </a:pPr>
             <a:r>
-              <a:rPr lang="en-US" sz="1300" b="1" dirty="0">
-                <a:solidFill>
-                  <a:srgbClr val="19241F"/>
+              <a:rPr lang="en-US" sz="1050" b="1" dirty="0">
+                <a:solidFill>
+                  <a:srgbClr val="1D6B57"/>
                 </a:solidFill>
                 <a:latin typeface="Microsoft YaHei" pitchFamily="34" charset="0"/>
                 <a:ea typeface="Microsoft YaHei" pitchFamily="34" charset="-122"/>
@@ -8523,7 +8523,7 @@
               </a:rPr>
               <a:t>行情与标的详情</a:t>
             </a:r>
-            <a:endParaRPr lang="en-US" sz="1300" dirty="0"/>
+            <a:endParaRPr lang="en-US" sz="1050" dirty="0"/>
           </a:p>
         </p:txBody>
       </p:sp>
@@ -8535,8 +8535,8 @@
         </p:nvSpPr>
         <p:spPr>
           <a:xfrm>
-            <a:off x="1719072" y="2569464"/>
-            <a:ext cx="3611880" cy="201168"/>
+            <a:off x="1719072" y="2633472"/>
+            <a:ext cx="2057400" cy="164592"/>
           </a:xfrm>
           <a:prstGeom prst="rect">
             <a:avLst/>
@@ -8554,7 +8554,7 @@
               <a:buNone/>
             </a:pPr>
             <a:r>
-              <a:rPr lang="en-US" sz="970" dirty="0">
+              <a:rPr lang="en-US" sz="810" dirty="0">
                 <a:solidFill>
                   <a:srgbClr val="5E665E"/>
                 </a:solidFill>
@@ -8564,7 +8564,7 @@
               </a:rPr>
               <a:t>Market / StockDetail / KLine</a:t>
             </a:r>
-            <a:endParaRPr lang="en-US" sz="970" dirty="0"/>
+            <a:endParaRPr lang="en-US" sz="810" dirty="0"/>
           </a:p>
         </p:txBody>
       </p:sp>
@@ -8576,12 +8576,12 @@
         </p:nvSpPr>
         <p:spPr>
           <a:xfrm>
-            <a:off x="6217920" y="1874520"/>
-            <a:ext cx="5056632" cy="1298448"/>
+            <a:off x="4379976" y="1828800"/>
+            <a:ext cx="3429000" cy="1188720"/>
           </a:xfrm>
           <a:prstGeom prst="roundRect">
             <a:avLst>
-              <a:gd name="adj" fmla="val 3521"/>
+              <a:gd name="adj" fmla="val 3846"/>
             </a:avLst>
           </a:prstGeom>
           <a:solidFill>
@@ -8603,7 +8603,7 @@
         </p:nvSpPr>
         <p:spPr>
           <a:xfrm>
-            <a:off x="6473952" y="2212848"/>
+            <a:off x="4636008" y="2167128"/>
             <a:ext cx="621792" cy="621792"/>
           </a:xfrm>
           <a:prstGeom prst="ellipse">
@@ -8628,7 +8628,7 @@
         </p:nvSpPr>
         <p:spPr>
           <a:xfrm>
-            <a:off x="6473952" y="2404872"/>
+            <a:off x="4636008" y="2359152"/>
             <a:ext cx="621792" cy="164592"/>
           </a:xfrm>
           <a:prstGeom prst="rect">
@@ -8655,7 +8655,7 @@
                 <a:ea typeface="Microsoft YaHei" pitchFamily="34" charset="-122"/>
                 <a:cs typeface="Microsoft YaHei" pitchFamily="34" charset="-120"/>
               </a:rPr>
-              <a:t>B</a:t>
+              <a:t>2</a:t>
             </a:r>
             <a:endParaRPr lang="en-US" sz="1100" dirty="0"/>
           </a:p>
@@ -8669,8 +8669,8 @@
         </p:nvSpPr>
         <p:spPr>
           <a:xfrm>
-            <a:off x="7296912" y="2112264"/>
-            <a:ext cx="914400" cy="228600"/>
+            <a:off x="5458968" y="2011680"/>
+            <a:ext cx="2057400" cy="219456"/>
           </a:xfrm>
           <a:prstGeom prst="rect">
             <a:avLst/>
@@ -8688,7 +8688,7 @@
               <a:buNone/>
             </a:pPr>
             <a:r>
-              <a:rPr lang="en-US" sz="1300" b="1" dirty="0">
+              <a:rPr lang="en-US" sz="1200" b="1" dirty="0">
                 <a:solidFill>
                   <a:srgbClr val="19241F"/>
                 </a:solidFill>
@@ -8696,9 +8696,9 @@
                 <a:ea typeface="Microsoft YaHei" pitchFamily="34" charset="-122"/>
                 <a:cs typeface="Microsoft YaHei" pitchFamily="34" charset="-120"/>
               </a:rPr>
-              <a:t>成员 B</a:t>
-            </a:r>
-            <a:endParaRPr lang="en-US" sz="1300" dirty="0"/>
+              <a:t>周金淼</a:t>
+            </a:r>
+            <a:endParaRPr lang="en-US" sz="1200" dirty="0"/>
           </a:p>
         </p:txBody>
       </p:sp>
@@ -8710,8 +8710,8 @@
         </p:nvSpPr>
         <p:spPr>
           <a:xfrm>
-            <a:off x="8211312" y="2112264"/>
-            <a:ext cx="2606040" cy="228600"/>
+            <a:off x="5458968" y="2295144"/>
+            <a:ext cx="2057400" cy="219456"/>
           </a:xfrm>
           <a:prstGeom prst="rect">
             <a:avLst/>
@@ -8729,9 +8729,9 @@
               <a:buNone/>
             </a:pPr>
             <a:r>
-              <a:rPr lang="en-US" sz="1300" b="1" dirty="0">
-                <a:solidFill>
-                  <a:srgbClr val="19241F"/>
+              <a:rPr lang="en-US" sz="1050" b="1" dirty="0">
+                <a:solidFill>
+                  <a:srgbClr val="1D6B57"/>
                 </a:solidFill>
                 <a:latin typeface="Microsoft YaHei" pitchFamily="34" charset="0"/>
                 <a:ea typeface="Microsoft YaHei" pitchFamily="34" charset="-122"/>
@@ -8739,7 +8739,7 @@
               </a:rPr>
               <a:t>模拟交易与个人资产</a:t>
             </a:r>
-            <a:endParaRPr lang="en-US" sz="1300" dirty="0"/>
+            <a:endParaRPr lang="en-US" sz="1050" dirty="0"/>
           </a:p>
         </p:txBody>
       </p:sp>
@@ -8751,8 +8751,8 @@
         </p:nvSpPr>
         <p:spPr>
           <a:xfrm>
-            <a:off x="7296912" y="2569464"/>
-            <a:ext cx="3611880" cy="201168"/>
+            <a:off x="5458968" y="2633472"/>
+            <a:ext cx="2057400" cy="164592"/>
           </a:xfrm>
           <a:prstGeom prst="rect">
             <a:avLst/>
@@ -8770,7 +8770,7 @@
               <a:buNone/>
             </a:pPr>
             <a:r>
-              <a:rPr lang="en-US" sz="970" dirty="0">
+              <a:rPr lang="en-US" sz="810" dirty="0">
                 <a:solidFill>
                   <a:srgbClr val="5E665E"/>
                 </a:solidFill>
@@ -8780,7 +8780,7 @@
               </a:rPr>
               <a:t>Trade / Profile / trade store</a:t>
             </a:r>
-            <a:endParaRPr lang="en-US" sz="970" dirty="0"/>
+            <a:endParaRPr lang="en-US" sz="810" dirty="0"/>
           </a:p>
         </p:txBody>
       </p:sp>
@@ -8792,12 +8792,12 @@
         </p:nvSpPr>
         <p:spPr>
           <a:xfrm>
-            <a:off x="640080" y="3566160"/>
-            <a:ext cx="5056632" cy="1298448"/>
+            <a:off x="8119872" y="1828800"/>
+            <a:ext cx="3429000" cy="1188720"/>
           </a:xfrm>
           <a:prstGeom prst="roundRect">
             <a:avLst>
-              <a:gd name="adj" fmla="val 3521"/>
+              <a:gd name="adj" fmla="val 3846"/>
             </a:avLst>
           </a:prstGeom>
           <a:solidFill>
@@ -8819,7 +8819,7 @@
         </p:nvSpPr>
         <p:spPr>
           <a:xfrm>
-            <a:off x="896112" y="3904488"/>
+            <a:off x="8375904" y="2167128"/>
             <a:ext cx="621792" cy="621792"/>
           </a:xfrm>
           <a:prstGeom prst="ellipse">
@@ -8844,7 +8844,7 @@
         </p:nvSpPr>
         <p:spPr>
           <a:xfrm>
-            <a:off x="896112" y="4096512"/>
+            <a:off x="8375904" y="2359152"/>
             <a:ext cx="621792" cy="164592"/>
           </a:xfrm>
           <a:prstGeom prst="rect">
@@ -8871,7 +8871,7 @@
                 <a:ea typeface="Microsoft YaHei" pitchFamily="34" charset="-122"/>
                 <a:cs typeface="Microsoft YaHei" pitchFamily="34" charset="-120"/>
               </a:rPr>
-              <a:t>C</a:t>
+              <a:t>3</a:t>
             </a:r>
             <a:endParaRPr lang="en-US" sz="1100" dirty="0"/>
           </a:p>
@@ -8885,8 +8885,8 @@
         </p:nvSpPr>
         <p:spPr>
           <a:xfrm>
-            <a:off x="1719072" y="3803904"/>
-            <a:ext cx="914400" cy="228600"/>
+            <a:off x="9198864" y="2011680"/>
+            <a:ext cx="2057400" cy="219456"/>
           </a:xfrm>
           <a:prstGeom prst="rect">
             <a:avLst/>
@@ -8904,7 +8904,7 @@
               <a:buNone/>
             </a:pPr>
             <a:r>
-              <a:rPr lang="en-US" sz="1300" b="1" dirty="0">
+              <a:rPr lang="en-US" sz="1200" b="1" dirty="0">
                 <a:solidFill>
                   <a:srgbClr val="19241F"/>
                 </a:solidFill>
@@ -8912,9 +8912,9 @@
                 <a:ea typeface="Microsoft YaHei" pitchFamily="34" charset="-122"/>
                 <a:cs typeface="Microsoft YaHei" pitchFamily="34" charset="-120"/>
               </a:rPr>
-              <a:t>成员 C</a:t>
-            </a:r>
-            <a:endParaRPr lang="en-US" sz="1300" dirty="0"/>
+              <a:t>张善言</a:t>
+            </a:r>
+            <a:endParaRPr lang="en-US" sz="1200" dirty="0"/>
           </a:p>
         </p:txBody>
       </p:sp>
@@ -8926,8 +8926,8 @@
         </p:nvSpPr>
         <p:spPr>
           <a:xfrm>
-            <a:off x="2633472" y="3803904"/>
-            <a:ext cx="2606040" cy="228600"/>
+            <a:off x="9198864" y="2295144"/>
+            <a:ext cx="2057400" cy="219456"/>
           </a:xfrm>
           <a:prstGeom prst="rect">
             <a:avLst/>
@@ -8945,17 +8945,17 @@
               <a:buNone/>
             </a:pPr>
             <a:r>
-              <a:rPr lang="en-US" sz="1300" b="1" dirty="0">
-                <a:solidFill>
-                  <a:srgbClr val="19241F"/>
-                </a:solidFill>
-                <a:latin typeface="Microsoft YaHei" pitchFamily="34" charset="0"/>
-                <a:ea typeface="Microsoft YaHei" pitchFamily="34" charset="-122"/>
-                <a:cs typeface="Microsoft YaHei" pitchFamily="34" charset="-120"/>
-              </a:rPr>
-              <a:t>评教、任务与排行榜</a:t>
-            </a:r>
-            <a:endParaRPr lang="en-US" sz="1300" dirty="0"/>
+              <a:rPr lang="en-US" sz="1050" b="1" dirty="0">
+                <a:solidFill>
+                  <a:srgbClr val="1D6B57"/>
+                </a:solidFill>
+                <a:latin typeface="Microsoft YaHei" pitchFamily="34" charset="0"/>
+                <a:ea typeface="Microsoft YaHei" pitchFamily="34" charset="-122"/>
+                <a:cs typeface="Microsoft YaHei" pitchFamily="34" charset="-120"/>
+              </a:rPr>
+              <a:t>评教与任务激励</a:t>
+            </a:r>
+            <a:endParaRPr lang="en-US" sz="1050" dirty="0"/>
           </a:p>
         </p:txBody>
       </p:sp>
@@ -8967,8 +8967,8 @@
         </p:nvSpPr>
         <p:spPr>
           <a:xfrm>
-            <a:off x="1719072" y="4261104"/>
-            <a:ext cx="3611880" cy="201168"/>
+            <a:off x="9198864" y="2633472"/>
+            <a:ext cx="2057400" cy="164592"/>
           </a:xfrm>
           <a:prstGeom prst="rect">
             <a:avLst/>
@@ -8986,7 +8986,7 @@
               <a:buNone/>
             </a:pPr>
             <a:r>
-              <a:rPr lang="en-US" sz="970" dirty="0">
+              <a:rPr lang="en-US" sz="810" dirty="0">
                 <a:solidFill>
                   <a:srgbClr val="5E665E"/>
                 </a:solidFill>
@@ -8994,9 +8994,9 @@
                 <a:ea typeface="Microsoft YaHei" pitchFamily="34" charset="-122"/>
                 <a:cs typeface="Microsoft YaHei" pitchFamily="34" charset="-120"/>
               </a:rPr>
-              <a:t>Evaluation / Task / Ranking</a:t>
-            </a:r>
-            <a:endParaRPr lang="en-US" sz="970" dirty="0"/>
+              <a:t>Evaluation / Task / Trend</a:t>
+            </a:r>
+            <a:endParaRPr lang="en-US" sz="810" dirty="0"/>
           </a:p>
         </p:txBody>
       </p:sp>
@@ -9008,12 +9008,12 @@
         </p:nvSpPr>
         <p:spPr>
           <a:xfrm>
-            <a:off x="6217920" y="3566160"/>
-            <a:ext cx="5056632" cy="1298448"/>
+            <a:off x="2505456" y="3456432"/>
+            <a:ext cx="3429000" cy="1188720"/>
           </a:xfrm>
           <a:prstGeom prst="roundRect">
             <a:avLst>
-              <a:gd name="adj" fmla="val 3521"/>
+              <a:gd name="adj" fmla="val 3846"/>
             </a:avLst>
           </a:prstGeom>
           <a:solidFill>
@@ -9035,7 +9035,7 @@
         </p:nvSpPr>
         <p:spPr>
           <a:xfrm>
-            <a:off x="6473952" y="3904488"/>
+            <a:off x="2761488" y="3794760"/>
             <a:ext cx="621792" cy="621792"/>
           </a:xfrm>
           <a:prstGeom prst="ellipse">
@@ -9060,7 +9060,7 @@
         </p:nvSpPr>
         <p:spPr>
           <a:xfrm>
-            <a:off x="6473952" y="4096512"/>
+            <a:off x="2761488" y="3986784"/>
             <a:ext cx="621792" cy="164592"/>
           </a:xfrm>
           <a:prstGeom prst="rect">
@@ -9087,7 +9087,7 @@
                 <a:ea typeface="Microsoft YaHei" pitchFamily="34" charset="-122"/>
                 <a:cs typeface="Microsoft YaHei" pitchFamily="34" charset="-120"/>
               </a:rPr>
-              <a:t>D</a:t>
+              <a:t>4</a:t>
             </a:r>
             <a:endParaRPr lang="en-US" sz="1100" dirty="0"/>
           </a:p>
@@ -9101,8 +9101,8 @@
         </p:nvSpPr>
         <p:spPr>
           <a:xfrm>
-            <a:off x="7296912" y="3803904"/>
-            <a:ext cx="914400" cy="228600"/>
+            <a:off x="3584448" y="3639312"/>
+            <a:ext cx="2057400" cy="219456"/>
           </a:xfrm>
           <a:prstGeom prst="rect">
             <a:avLst/>
@@ -9120,7 +9120,7 @@
               <a:buNone/>
             </a:pPr>
             <a:r>
-              <a:rPr lang="en-US" sz="1300" b="1" dirty="0">
+              <a:rPr lang="en-US" sz="1200" b="1" dirty="0">
                 <a:solidFill>
                   <a:srgbClr val="19241F"/>
                 </a:solidFill>
@@ -9128,9 +9128,9 @@
                 <a:ea typeface="Microsoft YaHei" pitchFamily="34" charset="-122"/>
                 <a:cs typeface="Microsoft YaHei" pitchFamily="34" charset="-120"/>
               </a:rPr>
-              <a:t>成员 D</a:t>
-            </a:r>
-            <a:endParaRPr lang="en-US" sz="1300" dirty="0"/>
+              <a:t>王溢诚</a:t>
+            </a:r>
+            <a:endParaRPr lang="en-US" sz="1200" dirty="0"/>
           </a:p>
         </p:txBody>
       </p:sp>
@@ -9142,8 +9142,8 @@
         </p:nvSpPr>
         <p:spPr>
           <a:xfrm>
-            <a:off x="8211312" y="3803904"/>
-            <a:ext cx="2606040" cy="228600"/>
+            <a:off x="3584448" y="3922776"/>
+            <a:ext cx="2057400" cy="219456"/>
           </a:xfrm>
           <a:prstGeom prst="rect">
             <a:avLst/>
@@ -9161,7 +9161,182 @@
               <a:buNone/>
             </a:pPr>
             <a:r>
-              <a:rPr lang="en-US" sz="1300" b="1" dirty="0">
+              <a:rPr lang="en-US" sz="1050" b="1" dirty="0">
+                <a:solidFill>
+                  <a:srgbClr val="1D6B57"/>
+                </a:solidFill>
+                <a:latin typeface="Microsoft YaHei" pitchFamily="34" charset="0"/>
+                <a:ea typeface="Microsoft YaHei" pitchFamily="34" charset="-122"/>
+                <a:cs typeface="Microsoft YaHei" pitchFamily="34" charset="-120"/>
+              </a:rPr>
+              <a:t>排行榜与管理端</a:t>
+            </a:r>
+            <a:endParaRPr lang="en-US" sz="1050" dirty="0"/>
+          </a:p>
+        </p:txBody>
+      </p:sp>
+      <p:sp>
+        <p:nvSpPr>
+          <p:cNvPr id="28" name="Text 26"/>
+          <p:cNvSpPr/>
+          <p:nvPr/>
+        </p:nvSpPr>
+        <p:spPr>
+          <a:xfrm>
+            <a:off x="3584448" y="4261104"/>
+            <a:ext cx="2057400" cy="164592"/>
+          </a:xfrm>
+          <a:prstGeom prst="rect">
+            <a:avLst/>
+          </a:prstGeom>
+          <a:noFill/>
+          <a:ln/>
+        </p:spPr>
+        <p:txBody>
+          <a:bodyPr wrap="square" lIns="0" tIns="0" rIns="0" bIns="0" rtlCol="0" anchor="ctr">
+            <a:normAutofit/>
+          </a:bodyPr>
+          <a:lstStyle/>
+          <a:p>
+            <a:pPr indent="0" marL="0">
+              <a:buNone/>
+            </a:pPr>
+            <a:r>
+              <a:rPr lang="en-US" sz="810" dirty="0">
+                <a:solidFill>
+                  <a:srgbClr val="5E665E"/>
+                </a:solidFill>
+                <a:latin typeface="Microsoft YaHei" pitchFamily="34" charset="0"/>
+                <a:ea typeface="Microsoft YaHei" pitchFamily="34" charset="-122"/>
+                <a:cs typeface="Microsoft YaHei" pitchFamily="34" charset="-120"/>
+              </a:rPr>
+              <a:t>Ranking / Admin / ranking store</a:t>
+            </a:r>
+            <a:endParaRPr lang="en-US" sz="810" dirty="0"/>
+          </a:p>
+        </p:txBody>
+      </p:sp>
+      <p:sp>
+        <p:nvSpPr>
+          <p:cNvPr id="29" name="Shape 27"/>
+          <p:cNvSpPr/>
+          <p:nvPr/>
+        </p:nvSpPr>
+        <p:spPr>
+          <a:xfrm>
+            <a:off x="6245352" y="3456432"/>
+            <a:ext cx="3429000" cy="1188720"/>
+          </a:xfrm>
+          <a:prstGeom prst="roundRect">
+            <a:avLst>
+              <a:gd name="adj" fmla="val 3846"/>
+            </a:avLst>
+          </a:prstGeom>
+          <a:solidFill>
+            <a:srgbClr val="FFFFFF"/>
+          </a:solidFill>
+          <a:ln w="8890">
+            <a:solidFill>
+              <a:srgbClr val="D7D0C4"/>
+            </a:solidFill>
+            <a:prstDash val="solid"/>
+          </a:ln>
+        </p:spPr>
+      </p:sp>
+      <p:sp>
+        <p:nvSpPr>
+          <p:cNvPr id="30" name="Shape 28"/>
+          <p:cNvSpPr/>
+          <p:nvPr/>
+        </p:nvSpPr>
+        <p:spPr>
+          <a:xfrm>
+            <a:off x="6501384" y="3794760"/>
+            <a:ext cx="621792" cy="621792"/>
+          </a:xfrm>
+          <a:prstGeom prst="ellipse">
+            <a:avLst/>
+          </a:prstGeom>
+          <a:solidFill>
+            <a:srgbClr val="E05A33"/>
+          </a:solidFill>
+          <a:ln w="12700">
+            <a:solidFill>
+              <a:srgbClr val="E05A33"/>
+            </a:solidFill>
+            <a:prstDash val="solid"/>
+          </a:ln>
+        </p:spPr>
+      </p:sp>
+      <p:sp>
+        <p:nvSpPr>
+          <p:cNvPr id="31" name="Text 29"/>
+          <p:cNvSpPr/>
+          <p:nvPr/>
+        </p:nvSpPr>
+        <p:spPr>
+          <a:xfrm>
+            <a:off x="6501384" y="3986784"/>
+            <a:ext cx="621792" cy="164592"/>
+          </a:xfrm>
+          <a:prstGeom prst="rect">
+            <a:avLst/>
+          </a:prstGeom>
+          <a:noFill/>
+          <a:ln/>
+        </p:spPr>
+        <p:txBody>
+          <a:bodyPr wrap="square" lIns="0" tIns="0" rIns="0" bIns="0" rtlCol="0" anchor="ctr">
+            <a:normAutofit/>
+          </a:bodyPr>
+          <a:lstStyle/>
+          <a:p>
+            <a:pPr algn="ctr" indent="0" marL="0">
+              <a:buNone/>
+            </a:pPr>
+            <a:r>
+              <a:rPr lang="en-US" sz="1100" b="1" dirty="0">
+                <a:solidFill>
+                  <a:srgbClr val="FFFFFF"/>
+                </a:solidFill>
+                <a:latin typeface="Microsoft YaHei" pitchFamily="34" charset="0"/>
+                <a:ea typeface="Microsoft YaHei" pitchFamily="34" charset="-122"/>
+                <a:cs typeface="Microsoft YaHei" pitchFamily="34" charset="-120"/>
+              </a:rPr>
+              <a:t>5</a:t>
+            </a:r>
+            <a:endParaRPr lang="en-US" sz="1100" dirty="0"/>
+          </a:p>
+        </p:txBody>
+      </p:sp>
+      <p:sp>
+        <p:nvSpPr>
+          <p:cNvPr id="32" name="Text 30"/>
+          <p:cNvSpPr/>
+          <p:nvPr/>
+        </p:nvSpPr>
+        <p:spPr>
+          <a:xfrm>
+            <a:off x="7324344" y="3639312"/>
+            <a:ext cx="2057400" cy="219456"/>
+          </a:xfrm>
+          <a:prstGeom prst="rect">
+            <a:avLst/>
+          </a:prstGeom>
+          <a:noFill/>
+          <a:ln/>
+        </p:spPr>
+        <p:txBody>
+          <a:bodyPr wrap="square" lIns="0" tIns="0" rIns="0" bIns="0" rtlCol="0" anchor="ctr">
+            <a:normAutofit/>
+          </a:bodyPr>
+          <a:lstStyle/>
+          <a:p>
+            <a:pPr indent="0" marL="0">
+              <a:buNone/>
+            </a:pPr>
+            <a:r>
+              <a:rPr lang="en-US" sz="1200" b="1" dirty="0">
                 <a:solidFill>
                   <a:srgbClr val="19241F"/>
                 </a:solidFill>
@@ -9169,22 +9344,22 @@
                 <a:ea typeface="Microsoft YaHei" pitchFamily="34" charset="-122"/>
                 <a:cs typeface="Microsoft YaHei" pitchFamily="34" charset="-120"/>
               </a:rPr>
-              <a:t>管理端与项目集成</a:t>
-            </a:r>
-            <a:endParaRPr lang="en-US" sz="1300" dirty="0"/>
-          </a:p>
-        </p:txBody>
-      </p:sp>
-      <p:sp>
-        <p:nvSpPr>
-          <p:cNvPr id="28" name="Text 26"/>
-          <p:cNvSpPr/>
-          <p:nvPr/>
-        </p:nvSpPr>
-        <p:spPr>
-          <a:xfrm>
-            <a:off x="7296912" y="4261104"/>
-            <a:ext cx="3611880" cy="201168"/>
+              <a:t>张宏瑜（组长）</a:t>
+            </a:r>
+            <a:endParaRPr lang="en-US" sz="1200" dirty="0"/>
+          </a:p>
+        </p:txBody>
+      </p:sp>
+      <p:sp>
+        <p:nvSpPr>
+          <p:cNvPr id="33" name="Text 31"/>
+          <p:cNvSpPr/>
+          <p:nvPr/>
+        </p:nvSpPr>
+        <p:spPr>
+          <a:xfrm>
+            <a:off x="7324344" y="3922776"/>
+            <a:ext cx="2057400" cy="219456"/>
           </a:xfrm>
           <a:prstGeom prst="rect">
             <a:avLst/>
@@ -9202,7 +9377,48 @@
               <a:buNone/>
             </a:pPr>
             <a:r>
-              <a:rPr lang="en-US" sz="970" dirty="0">
+              <a:rPr lang="en-US" sz="1050" b="1" dirty="0">
+                <a:solidFill>
+                  <a:srgbClr val="1D6B57"/>
+                </a:solidFill>
+                <a:latin typeface="Microsoft YaHei" pitchFamily="34" charset="0"/>
+                <a:ea typeface="Microsoft YaHei" pitchFamily="34" charset="-122"/>
+                <a:cs typeface="Microsoft YaHei" pitchFamily="34" charset="-120"/>
+              </a:rPr>
+              <a:t>统筹、文档与集成验收</a:t>
+            </a:r>
+            <a:endParaRPr lang="en-US" sz="1050" dirty="0"/>
+          </a:p>
+        </p:txBody>
+      </p:sp>
+      <p:sp>
+        <p:nvSpPr>
+          <p:cNvPr id="34" name="Text 32"/>
+          <p:cNvSpPr/>
+          <p:nvPr/>
+        </p:nvSpPr>
+        <p:spPr>
+          <a:xfrm>
+            <a:off x="7324344" y="4261104"/>
+            <a:ext cx="2057400" cy="164592"/>
+          </a:xfrm>
+          <a:prstGeom prst="rect">
+            <a:avLst/>
+          </a:prstGeom>
+          <a:noFill/>
+          <a:ln/>
+        </p:spPr>
+        <p:txBody>
+          <a:bodyPr wrap="square" lIns="0" tIns="0" rIns="0" bIns="0" rtlCol="0" anchor="ctr">
+            <a:normAutofit/>
+          </a:bodyPr>
+          <a:lstStyle/>
+          <a:p>
+            <a:pPr indent="0" marL="0">
+              <a:buNone/>
+            </a:pPr>
+            <a:r>
+              <a:rPr lang="en-US" sz="810" dirty="0">
                 <a:solidFill>
                   <a:srgbClr val="5E665E"/>
                 </a:solidFill>
@@ -9210,15 +9426,15 @@
                 <a:ea typeface="Microsoft YaHei" pitchFamily="34" charset="-122"/>
                 <a:cs typeface="Microsoft YaHei" pitchFamily="34" charset="-120"/>
               </a:rPr>
-              <a:t>Admin / Router / Types / QA</a:t>
-            </a:r>
-            <a:endParaRPr lang="en-US" sz="970" dirty="0"/>
-          </a:p>
-        </p:txBody>
-      </p:sp>
-      <p:sp>
-        <p:nvSpPr>
-          <p:cNvPr id="29" name="Text 27"/>
+              <a:t>Navbar / Router / Types / QA</a:t>
+            </a:r>
+            <a:endParaRPr lang="en-US" sz="810" dirty="0"/>
+          </a:p>
+        </p:txBody>
+      </p:sp>
+      <p:sp>
+        <p:nvSpPr>
+          <p:cNvPr id="35" name="Text 33"/>
           <p:cNvSpPr/>
           <p:nvPr/>
         </p:nvSpPr>

</xml_diff>